<commit_message>
Correct lecturer name to Vyacheslav Nepdov (נפדוב ויאצ׳לב)
Replaces the template author's name (Yakov Damatov) with the actual
course lecturer across the poster, abstract form, and project docs.

Co-Authored-By: Claude Opus 4.8 <noreply@anthropic.com>
</commit_message>
<xml_diff>
--- a/docs/MalwareGuard_Poster.pptx
+++ b/docs/MalwareGuard_Poster.pptx
@@ -3186,7 +3186,7 @@
                     <a:p>
                       <a:pPr marL="0" marR="0" lvl="0" indent="0" algn="ctr" defTabSz="2519995" rtl="0" eaLnBrk="1" fontAlgn="auto" latinLnBrk="0" hangingPunct="1">
                         <a:lnSpc>
-                          <a:spcPct val="100000"/>
+                          <a:spcPct val="92000"/>
                         </a:lnSpc>
                         <a:spcBef>
                           <a:spcPts val="0"/>
@@ -3207,7 +3207,7 @@
                             <a:srgbClr val="0A2540"/>
                           </a:solidFill>
                         </a:rPr>
-                        <a:t>Yakov Damatov</a:t>
+                        <a:t>Vyacheslav Nepdov</a:t>
                       </a:r>
                       <a:endParaRPr lang="en-GB" sz="5400" b="1" dirty="0">
                         <a:solidFill>
@@ -3216,7 +3216,7 @@
                       </a:endParaRPr>
                     </a:p>
                   </a:txBody>
-                  <a:tcPr anchor="ctr">
+                  <a:tcPr anchor="t" marT="54000" marB="18000">
                     <a:solidFill>
                       <a:srgbClr val="009999"/>
                     </a:solidFill>

</xml_diff>